<commit_message>
Fix peer review issues: bullet spacing & text overflow
- Slide 5: Reduce bullet spacing from 0.45in to 0.33in
- Slide 8: Shorten flow step descriptions to prevent overflow
- Slide 4: Text no longer overflows (fixed in v2)
- Slide 11: Font size increased (fixed in v2)

All critical issues resolved per peer review feedback.
</commit_message>
<xml_diff>
--- a/thuyet_minh_de_cuong.pptx
+++ b/thuyet_minh_de_cuong.pptx
@@ -6471,7 +6471,7 @@
           <a:lstStyle/>
           <a:p>
             <a:pPr algn="ctr">
-              <a:defRPr sz="900">
+              <a:defRPr sz="1100">
                 <a:solidFill>
                   <a:srgbClr val="2D3741"/>
                 </a:solidFill>
@@ -6621,7 +6621,7 @@
           <a:lstStyle/>
           <a:p>
             <a:pPr algn="ctr">
-              <a:defRPr sz="900">
+              <a:defRPr sz="1100">
                 <a:solidFill>
                   <a:srgbClr val="2D3741"/>
                 </a:solidFill>
@@ -6771,7 +6771,7 @@
           <a:lstStyle/>
           <a:p>
             <a:pPr algn="ctr">
-              <a:defRPr sz="900">
+              <a:defRPr sz="1100">
                 <a:solidFill>
                   <a:srgbClr val="2D3741"/>
                 </a:solidFill>
@@ -6921,7 +6921,7 @@
           <a:lstStyle/>
           <a:p>
             <a:pPr algn="ctr">
-              <a:defRPr sz="900">
+              <a:defRPr sz="1100">
                 <a:solidFill>
                   <a:srgbClr val="2D3741"/>
                 </a:solidFill>
@@ -7036,7 +7036,7 @@
           <a:lstStyle/>
           <a:p>
             <a:pPr>
-              <a:defRPr sz="1100">
+              <a:defRPr sz="1200">
                 <a:solidFill>
                   <a:srgbClr val="2D3741"/>
                 </a:solidFill>
@@ -7071,7 +7071,7 @@
           <a:lstStyle/>
           <a:p>
             <a:pPr>
-              <a:defRPr sz="1100">
+              <a:defRPr sz="1200">
                 <a:solidFill>
                   <a:srgbClr val="2D3741"/>
                 </a:solidFill>
@@ -7106,7 +7106,7 @@
           <a:lstStyle/>
           <a:p>
             <a:pPr>
-              <a:defRPr sz="1100">
+              <a:defRPr sz="1200">
                 <a:solidFill>
                   <a:srgbClr val="2D3741"/>
                 </a:solidFill>
@@ -7141,7 +7141,7 @@
           <a:lstStyle/>
           <a:p>
             <a:pPr>
-              <a:defRPr sz="1100">
+              <a:defRPr sz="1200">
                 <a:solidFill>
                   <a:srgbClr val="2D3741"/>
                 </a:solidFill>
@@ -12424,15 +12424,15 @@
           </a:bodyPr>
           <a:lstStyle/>
           <a:p>
-            <a:pPr>
-              <a:defRPr sz="1300">
+            <a:pPr algn="l">
+              <a:defRPr sz="1100">
                 <a:solidFill>
                   <a:srgbClr val="2D3741"/>
                 </a:solidFill>
               </a:defRPr>
             </a:pPr>
             <a:r>
-              <a:t>Xây dựng phòng thí nghiệm AI offline (AInatomy) giúp học sinh THPT phát triển năng lực kiểm chứng AI, đáp ứng yêu cầu của Chương trình giáo dục phổ thông 2018 và Quyết định 2422/QĐ-BGDĐT.</a:t>
+              <a:t>Xây dựng phòng thí nghiệm AI offline (AInatomy) giúp học sinh THPT phát triển năng lực kiểm chứng AI, đáp ứng Chương trình GDPT 2018 và QĐ 2422/QĐ-BGDĐT.</a:t>
             </a:r>
           </a:p>
         </p:txBody>
@@ -13233,7 +13233,7 @@
         <p:spPr>
           <a:xfrm>
             <a:off x="822960" y="2194560"/>
-            <a:ext cx="4937760" cy="365760"/>
+            <a:ext cx="4937760" cy="274320"/>
           </a:xfrm>
           <a:prstGeom prst="rect">
             <a:avLst/>
@@ -13267,8 +13267,8 @@
         </p:nvSpPr>
         <p:spPr>
           <a:xfrm>
-            <a:off x="822960" y="2606040"/>
-            <a:ext cx="4937760" cy="365760"/>
+            <a:off x="822960" y="2496312"/>
+            <a:ext cx="4937760" cy="274320"/>
           </a:xfrm>
           <a:prstGeom prst="rect">
             <a:avLst/>
@@ -13302,8 +13302,8 @@
         </p:nvSpPr>
         <p:spPr>
           <a:xfrm>
-            <a:off x="822960" y="3017520"/>
-            <a:ext cx="4937760" cy="365760"/>
+            <a:off x="822960" y="2798064"/>
+            <a:ext cx="4937760" cy="274320"/>
           </a:xfrm>
           <a:prstGeom prst="rect">
             <a:avLst/>
@@ -13337,8 +13337,8 @@
         </p:nvSpPr>
         <p:spPr>
           <a:xfrm>
-            <a:off x="822960" y="3429000"/>
-            <a:ext cx="4937760" cy="365760"/>
+            <a:off x="822960" y="3099815"/>
+            <a:ext cx="4937760" cy="274320"/>
           </a:xfrm>
           <a:prstGeom prst="rect">
             <a:avLst/>
@@ -13453,7 +13453,7 @@
         <p:spPr>
           <a:xfrm>
             <a:off x="6400800" y="2194560"/>
-            <a:ext cx="4937760" cy="365760"/>
+            <a:ext cx="4937760" cy="274320"/>
           </a:xfrm>
           <a:prstGeom prst="rect">
             <a:avLst/>
@@ -13487,8 +13487,8 @@
         </p:nvSpPr>
         <p:spPr>
           <a:xfrm>
-            <a:off x="6400800" y="2606040"/>
-            <a:ext cx="4937760" cy="365760"/>
+            <a:off x="6400800" y="2496312"/>
+            <a:ext cx="4937760" cy="274320"/>
           </a:xfrm>
           <a:prstGeom prst="rect">
             <a:avLst/>
@@ -13522,8 +13522,8 @@
         </p:nvSpPr>
         <p:spPr>
           <a:xfrm>
-            <a:off x="6400800" y="3017520"/>
-            <a:ext cx="4937760" cy="365760"/>
+            <a:off x="6400800" y="2798064"/>
+            <a:ext cx="4937760" cy="274320"/>
           </a:xfrm>
           <a:prstGeom prst="rect">
             <a:avLst/>
@@ -13557,8 +13557,8 @@
         </p:nvSpPr>
         <p:spPr>
           <a:xfrm>
-            <a:off x="6400800" y="3429000"/>
-            <a:ext cx="4937760" cy="365760"/>
+            <a:off x="6400800" y="3099815"/>
+            <a:ext cx="4937760" cy="274320"/>
           </a:xfrm>
           <a:prstGeom prst="rect">
             <a:avLst/>
@@ -15876,7 +15876,7 @@
         <p:spPr>
           <a:xfrm>
             <a:off x="1280160" y="2971800"/>
-            <a:ext cx="2011680" cy="274320"/>
+            <a:ext cx="2286000" cy="274320"/>
           </a:xfrm>
           <a:prstGeom prst="rect">
             <a:avLst/>
@@ -15911,7 +15911,7 @@
         <p:spPr>
           <a:xfrm>
             <a:off x="1280160" y="3246120"/>
-            <a:ext cx="2011680" cy="457200"/>
+            <a:ext cx="2286000" cy="457200"/>
           </a:xfrm>
           <a:prstGeom prst="rect">
             <a:avLst/>
@@ -15932,7 +15932,7 @@
               </a:defRPr>
             </a:pPr>
             <a:r>
-              <a:t>Học sinh đọc tình huống, nhận diện vấn đề</a:t>
+              <a:t>Đọc tình huống, nhận diện vấn đề</a:t>
             </a:r>
           </a:p>
         </p:txBody>
@@ -15998,7 +15998,7 @@
         <p:spPr>
           <a:xfrm>
             <a:off x="4069080" y="2971800"/>
-            <a:ext cx="2011680" cy="274320"/>
+            <a:ext cx="2286000" cy="274320"/>
           </a:xfrm>
           <a:prstGeom prst="rect">
             <a:avLst/>
@@ -16033,7 +16033,7 @@
         <p:spPr>
           <a:xfrm>
             <a:off x="4069080" y="3246120"/>
-            <a:ext cx="2011680" cy="457200"/>
+            <a:ext cx="2286000" cy="457200"/>
           </a:xfrm>
           <a:prstGeom prst="rect">
             <a:avLst/>
@@ -16054,7 +16054,7 @@
               </a:defRPr>
             </a:pPr>
             <a:r>
-              <a:t>Học sinh dự đoán đầu ra AI trước khi xem kết quả</a:t>
+              <a:t>Dự đoán đầu ra AI trước khi xem</a:t>
             </a:r>
           </a:p>
         </p:txBody>
@@ -16120,7 +16120,7 @@
         <p:spPr>
           <a:xfrm>
             <a:off x="6858000" y="2971800"/>
-            <a:ext cx="2011680" cy="274320"/>
+            <a:ext cx="2286000" cy="274320"/>
           </a:xfrm>
           <a:prstGeom prst="rect">
             <a:avLst/>
@@ -16155,7 +16155,7 @@
         <p:spPr>
           <a:xfrm>
             <a:off x="6858000" y="3246120"/>
-            <a:ext cx="2011680" cy="457200"/>
+            <a:ext cx="2286000" cy="457200"/>
           </a:xfrm>
           <a:prstGeom prst="rect">
             <a:avLst/>
@@ -16176,7 +16176,7 @@
               </a:defRPr>
             </a:pPr>
             <a:r>
-              <a:t>Học sinh chạy mô phỏng AI, quan sát quy trình</a:t>
+              <a:t>Chạy mô phỏng, quan sát quy trình</a:t>
             </a:r>
           </a:p>
         </p:txBody>
@@ -16242,7 +16242,7 @@
         <p:spPr>
           <a:xfrm>
             <a:off x="9646919" y="2971800"/>
-            <a:ext cx="2011680" cy="274320"/>
+            <a:ext cx="2286000" cy="274320"/>
           </a:xfrm>
           <a:prstGeom prst="rect">
             <a:avLst/>
@@ -16277,7 +16277,7 @@
         <p:spPr>
           <a:xfrm>
             <a:off x="9646919" y="3246120"/>
-            <a:ext cx="2011680" cy="457200"/>
+            <a:ext cx="2286000" cy="457200"/>
           </a:xfrm>
           <a:prstGeom prst="rect">
             <a:avLst/>
@@ -16298,7 +16298,7 @@
               </a:defRPr>
             </a:pPr>
             <a:r>
-              <a:t>Học sinh so sánh dự đoán với kết quả, rút ra bài học</a:t>
+              <a:t>So sánh dự đoán với kết quả, rút bài học</a:t>
             </a:r>
           </a:p>
         </p:txBody>

</xml_diff>